<commit_message>
fix: remove affiliation from slides
</commit_message>
<xml_diff>
--- a/RADAR_Presentation.pptx
+++ b/RADAR_Presentation.pptx
@@ -3295,7 +3295,7 @@
               </a:defRPr>
             </a:pPr>
             <a:r>
-              <a:t>MIT Critical Data | Dr. Leo Anthony Celi</a:t>
+              <a:t>MIT Critical Data |</a:t>
             </a:r>
           </a:p>
         </p:txBody>
@@ -6717,7 +6717,7 @@
               </a:defRPr>
             </a:pPr>
             <a:r>
-              <a:t>MIT Critical Data — Dr. Leo Anthony Celi</a:t>
+              <a:t>MIT Critical Data —</a:t>
             </a:r>
           </a:p>
         </p:txBody>

</xml_diff>